<commit_message>
Fix: regenerate slides with correct full rendering (CDP capture)
</commit_message>
<xml_diff>
--- a/slides/FineVAD_组会PPT.pptx
+++ b/slides/FineVAD_组会PPT.pptx
@@ -4260,7 +4260,7 @@
       <p:grpSpPr/>
       <p:pic>
         <p:nvPicPr>
-          <p:cNvPr id="2" name="Picture 1" descr="slide-1.png"/>
+          <p:cNvPr id="2" name="Picture 1" descr="cdp-1.png"/>
           <p:cNvPicPr>
             <a:picLocks noChangeAspect="1"/>
           </p:cNvPicPr>
@@ -4302,7 +4302,7 @@
       <p:grpSpPr/>
       <p:pic>
         <p:nvPicPr>
-          <p:cNvPr id="2" name="Picture 1" descr="slide-2.png"/>
+          <p:cNvPr id="2" name="Picture 1" descr="cdp-2.png"/>
           <p:cNvPicPr>
             <a:picLocks noChangeAspect="1"/>
           </p:cNvPicPr>
@@ -4344,7 +4344,7 @@
       <p:grpSpPr/>
       <p:pic>
         <p:nvPicPr>
-          <p:cNvPr id="2" name="Picture 1" descr="slide-3.png"/>
+          <p:cNvPr id="2" name="Picture 1" descr="cdp-3.png"/>
           <p:cNvPicPr>
             <a:picLocks noChangeAspect="1"/>
           </p:cNvPicPr>
@@ -4386,7 +4386,7 @@
       <p:grpSpPr/>
       <p:pic>
         <p:nvPicPr>
-          <p:cNvPr id="2" name="Picture 1" descr="slide-4.png"/>
+          <p:cNvPr id="2" name="Picture 1" descr="cdp-4.png"/>
           <p:cNvPicPr>
             <a:picLocks noChangeAspect="1"/>
           </p:cNvPicPr>
@@ -4428,7 +4428,7 @@
       <p:grpSpPr/>
       <p:pic>
         <p:nvPicPr>
-          <p:cNvPr id="2" name="Picture 1" descr="slide-5.png"/>
+          <p:cNvPr id="2" name="Picture 1" descr="cdp-5.png"/>
           <p:cNvPicPr>
             <a:picLocks noChangeAspect="1"/>
           </p:cNvPicPr>
@@ -4470,7 +4470,7 @@
       <p:grpSpPr/>
       <p:pic>
         <p:nvPicPr>
-          <p:cNvPr id="2" name="Picture 1" descr="slide-6.png"/>
+          <p:cNvPr id="2" name="Picture 1" descr="cdp-6.png"/>
           <p:cNvPicPr>
             <a:picLocks noChangeAspect="1"/>
           </p:cNvPicPr>
@@ -4512,7 +4512,7 @@
       <p:grpSpPr/>
       <p:pic>
         <p:nvPicPr>
-          <p:cNvPr id="2" name="Picture 1" descr="slide-7.png"/>
+          <p:cNvPr id="2" name="Picture 1" descr="cdp-7.png"/>
           <p:cNvPicPr>
             <a:picLocks noChangeAspect="1"/>
           </p:cNvPicPr>

</xml_diff>